<commit_message>
Larger text in rates figure
</commit_message>
<xml_diff>
--- a/img/rates.pptx
+++ b/img/rates.pptx
@@ -254,7 +254,7 @@
           <a:p>
             <a:fld id="{918BE157-C9BD-DB4B-B849-501D8C18A188}" type="datetimeFigureOut">
               <a:rPr lang="en-US" smtClean="0"/>
-              <a:t>6/2/26</a:t>
+              <a:t>6/3/26</a:t>
             </a:fld>
             <a:endParaRPr lang="en-US"/>
           </a:p>
@@ -424,7 +424,7 @@
           <a:p>
             <a:fld id="{918BE157-C9BD-DB4B-B849-501D8C18A188}" type="datetimeFigureOut">
               <a:rPr lang="en-US" smtClean="0"/>
-              <a:t>6/2/26</a:t>
+              <a:t>6/3/26</a:t>
             </a:fld>
             <a:endParaRPr lang="en-US"/>
           </a:p>
@@ -604,7 +604,7 @@
           <a:p>
             <a:fld id="{918BE157-C9BD-DB4B-B849-501D8C18A188}" type="datetimeFigureOut">
               <a:rPr lang="en-US" smtClean="0"/>
-              <a:t>6/2/26</a:t>
+              <a:t>6/3/26</a:t>
             </a:fld>
             <a:endParaRPr lang="en-US"/>
           </a:p>
@@ -774,7 +774,7 @@
           <a:p>
             <a:fld id="{918BE157-C9BD-DB4B-B849-501D8C18A188}" type="datetimeFigureOut">
               <a:rPr lang="en-US" smtClean="0"/>
-              <a:t>6/2/26</a:t>
+              <a:t>6/3/26</a:t>
             </a:fld>
             <a:endParaRPr lang="en-US"/>
           </a:p>
@@ -1020,7 +1020,7 @@
           <a:p>
             <a:fld id="{918BE157-C9BD-DB4B-B849-501D8C18A188}" type="datetimeFigureOut">
               <a:rPr lang="en-US" smtClean="0"/>
-              <a:t>6/2/26</a:t>
+              <a:t>6/3/26</a:t>
             </a:fld>
             <a:endParaRPr lang="en-US"/>
           </a:p>
@@ -1252,7 +1252,7 @@
           <a:p>
             <a:fld id="{918BE157-C9BD-DB4B-B849-501D8C18A188}" type="datetimeFigureOut">
               <a:rPr lang="en-US" smtClean="0"/>
-              <a:t>6/2/26</a:t>
+              <a:t>6/3/26</a:t>
             </a:fld>
             <a:endParaRPr lang="en-US"/>
           </a:p>
@@ -1619,7 +1619,7 @@
           <a:p>
             <a:fld id="{918BE157-C9BD-DB4B-B849-501D8C18A188}" type="datetimeFigureOut">
               <a:rPr lang="en-US" smtClean="0"/>
-              <a:t>6/2/26</a:t>
+              <a:t>6/3/26</a:t>
             </a:fld>
             <a:endParaRPr lang="en-US"/>
           </a:p>
@@ -1737,7 +1737,7 @@
           <a:p>
             <a:fld id="{918BE157-C9BD-DB4B-B849-501D8C18A188}" type="datetimeFigureOut">
               <a:rPr lang="en-US" smtClean="0"/>
-              <a:t>6/2/26</a:t>
+              <a:t>6/3/26</a:t>
             </a:fld>
             <a:endParaRPr lang="en-US"/>
           </a:p>
@@ -1832,7 +1832,7 @@
           <a:p>
             <a:fld id="{918BE157-C9BD-DB4B-B849-501D8C18A188}" type="datetimeFigureOut">
               <a:rPr lang="en-US" smtClean="0"/>
-              <a:t>6/2/26</a:t>
+              <a:t>6/3/26</a:t>
             </a:fld>
             <a:endParaRPr lang="en-US"/>
           </a:p>
@@ -2109,7 +2109,7 @@
           <a:p>
             <a:fld id="{918BE157-C9BD-DB4B-B849-501D8C18A188}" type="datetimeFigureOut">
               <a:rPr lang="en-US" smtClean="0"/>
-              <a:t>6/2/26</a:t>
+              <a:t>6/3/26</a:t>
             </a:fld>
             <a:endParaRPr lang="en-US"/>
           </a:p>
@@ -2366,7 +2366,7 @@
           <a:p>
             <a:fld id="{918BE157-C9BD-DB4B-B849-501D8C18A188}" type="datetimeFigureOut">
               <a:rPr lang="en-US" smtClean="0"/>
-              <a:t>6/2/26</a:t>
+              <a:t>6/3/26</a:t>
             </a:fld>
             <a:endParaRPr lang="en-US"/>
           </a:p>
@@ -2579,7 +2579,7 @@
           <a:p>
             <a:fld id="{918BE157-C9BD-DB4B-B849-501D8C18A188}" type="datetimeFigureOut">
               <a:rPr lang="en-US" smtClean="0"/>
-              <a:t>6/2/26</a:t>
+              <a:t>6/3/26</a:t>
             </a:fld>
             <a:endParaRPr lang="en-US"/>
           </a:p>
@@ -3049,15 +3049,12 @@
             <a:lstStyle/>
             <a:p>
               <a:pPr algn="ctr"/>
-              <a:r>
-                <a:rPr lang="en-US" sz="1550" dirty="0">
-                  <a:solidFill>
-                    <a:schemeClr val="tx1"/>
-                  </a:solidFill>
-                  <a:latin typeface="Helvetica" pitchFamily="2" charset="0"/>
-                </a:rPr>
-                <a:t>Absence of distinctions</a:t>
-              </a:r>
+              <a:endParaRPr lang="en-US" sz="1550" dirty="0">
+                <a:solidFill>
+                  <a:schemeClr val="tx1"/>
+                </a:solidFill>
+                <a:latin typeface="Helvetica" pitchFamily="2" charset="0"/>
+              </a:endParaRPr>
             </a:p>
           </p:txBody>
         </p:sp>
@@ -3106,15 +3103,12 @@
             <a:lstStyle/>
             <a:p>
               <a:pPr algn="ctr"/>
-              <a:r>
-                <a:rPr lang="en-US" sz="1550" dirty="0">
-                  <a:solidFill>
-                    <a:schemeClr val="tx1"/>
-                  </a:solidFill>
-                  <a:latin typeface="Helvetica" pitchFamily="2" charset="0"/>
-                </a:rPr>
-                <a:t>Wealth distinctions</a:t>
-              </a:r>
+              <a:endParaRPr lang="en-US" sz="1550" dirty="0">
+                <a:solidFill>
+                  <a:schemeClr val="tx1"/>
+                </a:solidFill>
+                <a:latin typeface="Helvetica" pitchFamily="2" charset="0"/>
+              </a:endParaRPr>
             </a:p>
           </p:txBody>
         </p:sp>
@@ -3167,15 +3161,12 @@
                   <a:tab pos="1063625" algn="l"/>
                 </a:tabLst>
               </a:pPr>
-              <a:r>
-                <a:rPr lang="en-US" sz="1500" dirty="0">
-                  <a:solidFill>
-                    <a:schemeClr val="tx1"/>
-                  </a:solidFill>
-                  <a:latin typeface="Helvetica" pitchFamily="2" charset="0"/>
-                </a:rPr>
-                <a:t>Stratification</a:t>
-              </a:r>
+              <a:endParaRPr lang="en-US" sz="1500" dirty="0">
+                <a:solidFill>
+                  <a:schemeClr val="tx1"/>
+                </a:solidFill>
+                <a:latin typeface="Helvetica" pitchFamily="2" charset="0"/>
+              </a:endParaRPr>
             </a:p>
           </p:txBody>
         </p:sp>
@@ -3413,8 +3404,8 @@
         </p:nvSpPr>
         <p:spPr>
           <a:xfrm>
-            <a:off x="2613807" y="905932"/>
-            <a:ext cx="1160895" cy="261610"/>
+            <a:off x="2555553" y="864121"/>
+            <a:ext cx="1252266" cy="276999"/>
           </a:xfrm>
           <a:prstGeom prst="rect">
             <a:avLst/>
@@ -3428,7 +3419,7 @@
           <a:lstStyle/>
           <a:p>
             <a:r>
-              <a:rPr lang="en-US" sz="1100" dirty="0">
+              <a:rPr lang="en-US" sz="1200" dirty="0">
                 <a:latin typeface="Helvetica" pitchFamily="2" charset="0"/>
               </a:rPr>
               <a:t>0.16 [0.12 0.27]</a:t>
@@ -3450,8 +3441,8 @@
         </p:nvSpPr>
         <p:spPr>
           <a:xfrm>
-            <a:off x="5283090" y="905932"/>
-            <a:ext cx="1160895" cy="261610"/>
+            <a:off x="5219849" y="864121"/>
+            <a:ext cx="1252266" cy="276999"/>
           </a:xfrm>
           <a:prstGeom prst="rect">
             <a:avLst/>
@@ -3465,7 +3456,7 @@
           <a:lstStyle/>
           <a:p>
             <a:r>
-              <a:rPr lang="en-US" sz="1100" dirty="0">
+              <a:rPr lang="en-US" sz="1200" dirty="0">
                 <a:latin typeface="Helvetica" pitchFamily="2" charset="0"/>
               </a:rPr>
               <a:t>0.61 [0.37 1.22]</a:t>
@@ -3487,8 +3478,8 @@
         </p:nvSpPr>
         <p:spPr>
           <a:xfrm>
-            <a:off x="2550566" y="1980098"/>
-            <a:ext cx="1160895" cy="261610"/>
+            <a:off x="2550566" y="2027282"/>
+            <a:ext cx="1252266" cy="276999"/>
           </a:xfrm>
           <a:prstGeom prst="rect">
             <a:avLst/>
@@ -3502,7 +3493,7 @@
           <a:lstStyle/>
           <a:p>
             <a:r>
-              <a:rPr lang="en-US" sz="1100" dirty="0">
+              <a:rPr lang="en-US" sz="1200" dirty="0">
                 <a:latin typeface="Helvetica" pitchFamily="2" charset="0"/>
               </a:rPr>
               <a:t>0.17 [0.01 0.57]</a:t>
@@ -3524,8 +3515,8 @@
         </p:nvSpPr>
         <p:spPr>
           <a:xfrm>
-            <a:off x="5219849" y="1980098"/>
-            <a:ext cx="1160895" cy="261610"/>
+            <a:off x="5219849" y="2027282"/>
+            <a:ext cx="1240917" cy="276999"/>
           </a:xfrm>
           <a:prstGeom prst="rect">
             <a:avLst/>
@@ -3539,7 +3530,7 @@
           <a:lstStyle/>
           <a:p>
             <a:r>
-              <a:rPr lang="en-US" sz="1100" dirty="0">
+              <a:rPr lang="en-US" sz="1200" dirty="0">
                 <a:latin typeface="Helvetica" pitchFamily="2" charset="0"/>
               </a:rPr>
               <a:t>0.22 [0.11 0.51]</a:t>
@@ -3561,8 +3552,8 @@
         </p:nvSpPr>
         <p:spPr>
           <a:xfrm>
-            <a:off x="3914938" y="2690743"/>
-            <a:ext cx="1160895" cy="261610"/>
+            <a:off x="3873636" y="2664321"/>
+            <a:ext cx="1252266" cy="276999"/>
           </a:xfrm>
           <a:prstGeom prst="rect">
             <a:avLst/>
@@ -3576,10 +3567,124 @@
           <a:lstStyle/>
           <a:p>
             <a:r>
-              <a:rPr lang="en-US" sz="1100" dirty="0">
+              <a:rPr lang="en-US" sz="1200" dirty="0">
                 <a:latin typeface="Helvetica" pitchFamily="2" charset="0"/>
               </a:rPr>
               <a:t>0.20 [0.10 0.29]</a:t>
+            </a:r>
+          </a:p>
+        </p:txBody>
+      </p:sp>
+      <p:sp>
+        <p:nvSpPr>
+          <p:cNvPr id="4" name="TextBox 3">
+            <a:extLst>
+              <a:ext uri="{FF2B5EF4-FFF2-40B4-BE49-F238E27FC236}">
+                <a16:creationId xmlns:a16="http://schemas.microsoft.com/office/drawing/2014/main" id="{D46A5D51-4C5C-057A-112A-7A7D5880F8B3}"/>
+              </a:ext>
+            </a:extLst>
+          </p:cNvPr>
+          <p:cNvSpPr txBox="1"/>
+          <p:nvPr/>
+        </p:nvSpPr>
+        <p:spPr>
+          <a:xfrm>
+            <a:off x="1016373" y="1236355"/>
+            <a:ext cx="1611188" cy="707886"/>
+          </a:xfrm>
+          <a:prstGeom prst="rect">
+            <a:avLst/>
+          </a:prstGeom>
+          <a:noFill/>
+        </p:spPr>
+        <p:txBody>
+          <a:bodyPr wrap="square" rtlCol="0">
+            <a:spAutoFit/>
+          </a:bodyPr>
+          <a:lstStyle/>
+          <a:p>
+            <a:pPr algn="ctr"/>
+            <a:r>
+              <a:rPr lang="en-US" sz="2000" dirty="0">
+                <a:latin typeface="Helvetica" pitchFamily="2" charset="0"/>
+              </a:rPr>
+              <a:t>Absence of distinctions</a:t>
+            </a:r>
+          </a:p>
+        </p:txBody>
+      </p:sp>
+      <p:sp>
+        <p:nvSpPr>
+          <p:cNvPr id="5" name="TextBox 4">
+            <a:extLst>
+              <a:ext uri="{FF2B5EF4-FFF2-40B4-BE49-F238E27FC236}">
+                <a16:creationId xmlns:a16="http://schemas.microsoft.com/office/drawing/2014/main" id="{59260A5C-E5DC-91F7-C9B7-A8C74C5C640D}"/>
+              </a:ext>
+            </a:extLst>
+          </p:cNvPr>
+          <p:cNvSpPr txBox="1"/>
+          <p:nvPr/>
+        </p:nvSpPr>
+        <p:spPr>
+          <a:xfrm>
+            <a:off x="3694969" y="1234666"/>
+            <a:ext cx="1611188" cy="707886"/>
+          </a:xfrm>
+          <a:prstGeom prst="rect">
+            <a:avLst/>
+          </a:prstGeom>
+          <a:noFill/>
+        </p:spPr>
+        <p:txBody>
+          <a:bodyPr wrap="square" rtlCol="0">
+            <a:spAutoFit/>
+          </a:bodyPr>
+          <a:lstStyle/>
+          <a:p>
+            <a:pPr algn="ctr"/>
+            <a:r>
+              <a:rPr lang="en-US" sz="2000" dirty="0">
+                <a:latin typeface="Helvetica" pitchFamily="2" charset="0"/>
+              </a:rPr>
+              <a:t>Wealth distinctions</a:t>
+            </a:r>
+          </a:p>
+        </p:txBody>
+      </p:sp>
+      <p:sp>
+        <p:nvSpPr>
+          <p:cNvPr id="6" name="TextBox 5">
+            <a:extLst>
+              <a:ext uri="{FF2B5EF4-FFF2-40B4-BE49-F238E27FC236}">
+                <a16:creationId xmlns:a16="http://schemas.microsoft.com/office/drawing/2014/main" id="{47092B40-2018-A321-176E-1D2229D7BDFD}"/>
+              </a:ext>
+            </a:extLst>
+          </p:cNvPr>
+          <p:cNvSpPr txBox="1"/>
+          <p:nvPr/>
+        </p:nvSpPr>
+        <p:spPr>
+          <a:xfrm>
+            <a:off x="6351623" y="1373765"/>
+            <a:ext cx="1611188" cy="400110"/>
+          </a:xfrm>
+          <a:prstGeom prst="rect">
+            <a:avLst/>
+          </a:prstGeom>
+          <a:noFill/>
+        </p:spPr>
+        <p:txBody>
+          <a:bodyPr wrap="square" rtlCol="0">
+            <a:spAutoFit/>
+          </a:bodyPr>
+          <a:lstStyle/>
+          <a:p>
+            <a:pPr algn="ctr"/>
+            <a:r>
+              <a:rPr lang="en-US" sz="2000" dirty="0">
+                <a:latin typeface="Helvetica" pitchFamily="2" charset="0"/>
+              </a:rPr>
+              <a:t>Stratification</a:t>
             </a:r>
           </a:p>
         </p:txBody>

</xml_diff>